<commit_message>
Finalize TOSEA presentation deliverable
Co-authored-by: sunnytan562-create <315787137+sunnytan562-create@users.noreply.github.com>
</commit_message>
<xml_diff>
--- a/presentation/泰卦外贸团队系统.pptx
+++ b/presentation/泰卦外贸团队系统.pptx
@@ -4938,7 +4938,7 @@
           <a:lstStyle/>
           <a:p>
             <a:pPr algn="ctr">
-              <a:defRPr b="1" sz="1400">
+              <a:defRPr sz="1400" b="1">
                 <a:solidFill>
                   <a:srgbClr val="FFFFFF"/>
                 </a:solidFill>
@@ -4992,7 +4992,7 @@
           <a:lstStyle/>
           <a:p>
             <a:pPr algn="ctr">
-              <a:defRPr b="1" sz="1400">
+              <a:defRPr sz="1400" b="1">
                 <a:solidFill>
                   <a:srgbClr val="FFFFFF"/>
                 </a:solidFill>
@@ -5046,7 +5046,7 @@
           <a:lstStyle/>
           <a:p>
             <a:pPr algn="ctr">
-              <a:defRPr b="1" sz="1400">
+              <a:defRPr sz="1400" b="1">
                 <a:solidFill>
                   <a:srgbClr val="FFFFFF"/>
                 </a:solidFill>
@@ -5100,7 +5100,7 @@
           <a:lstStyle/>
           <a:p>
             <a:pPr algn="ctr">
-              <a:defRPr b="1" sz="1400">
+              <a:defRPr sz="1400" b="1">
                 <a:solidFill>
                   <a:srgbClr val="FFFFFF"/>
                 </a:solidFill>
@@ -5154,7 +5154,7 @@
           <a:lstStyle/>
           <a:p>
             <a:pPr algn="ctr">
-              <a:defRPr b="1" sz="1400">
+              <a:defRPr sz="1400" b="1">
                 <a:solidFill>
                   <a:srgbClr val="FFFFFF"/>
                 </a:solidFill>
@@ -5208,7 +5208,7 @@
           <a:lstStyle/>
           <a:p>
             <a:pPr algn="ctr">
-              <a:defRPr b="1" sz="1400">
+              <a:defRPr sz="1400" b="1">
                 <a:solidFill>
                   <a:srgbClr val="FFFFFF"/>
                 </a:solidFill>
@@ -6934,7 +6934,7 @@
           <a:lstStyle/>
           <a:p>
             <a:pPr algn="ctr">
-              <a:defRPr b="1" sz="1400">
+              <a:defRPr sz="1400" b="1">
                 <a:solidFill>
                   <a:srgbClr val="FFFFFF"/>
                 </a:solidFill>
@@ -6988,7 +6988,7 @@
           <a:lstStyle/>
           <a:p>
             <a:pPr algn="ctr">
-              <a:defRPr b="1" sz="1400">
+              <a:defRPr sz="1400" b="1">
                 <a:solidFill>
                   <a:srgbClr val="FFFFFF"/>
                 </a:solidFill>
@@ -9586,7 +9586,7 @@
           <a:lstStyle/>
           <a:p>
             <a:pPr algn="ctr">
-              <a:defRPr b="1" sz="1600">
+              <a:defRPr sz="1600" b="1">
                 <a:solidFill>
                   <a:srgbClr val="FFFFFF"/>
                 </a:solidFill>
@@ -9595,15 +9595,7 @@
             <a:r>
               <a:t>业务增长闭环</a:t>
             </a:r>
-          </a:p>
-          <a:p>
-            <a:pPr algn="ctr">
-              <a:defRPr b="1" sz="1600">
-                <a:solidFill>
-                  <a:srgbClr val="FFFFFF"/>
-                </a:solidFill>
-              </a:defRPr>
-            </a:pPr>
+            <a:br/>
             <a:r>
               <a:t>标准化推进</a:t>
             </a:r>

</xml_diff>